<commit_message>
Completar memoria de cálculo FEA para las 4 propuestas (P1–P4)
- Memoria completa: resumen y conclusiones (sección 1), P3 y P4 en todas
  las secciones, modelo reconstruido (5.1), lectura en tensión plana (5.2),
  verificación manual de P3/P4 (9.1) y versiones P1-M/P2-M (sección 10).
- Modelo CalculiX reconstruido de los siete diseños (inp y scripts) y
  resultados en Excel.
- STEP de P3 y P4 con diafragmas y rompeolas de la extensión.
- Presentación alineada con las capacidades del método Komatsu.

Co-Authored-By: Claude Opus 5.5 <noreply@anthropic.com>
Claude-Session: https://claude.ai/code/session_01TixyxqUNmuV7iGi3jJYj2g
</commit_message>
<xml_diff>
--- a/Presentacion_Ampliacion_Tanque_980E5_1700gal.pptx
+++ b/Presentacion_Ampliacion_Tanque_980E5_1700gal.pptx
@@ -104,13 +104,13 @@
                   <c:v>29.7</c:v>
                 </c:pt>
                 <c:pt idx="1">
-                  <c:v>68.0</c:v>
+                  <c:v>67.5</c:v>
                 </c:pt>
                 <c:pt idx="2">
                   <c:v>73.6</c:v>
                 </c:pt>
                 <c:pt idx="3">
-                  <c:v>76.1</c:v>
+                  <c:v>75.7</c:v>
                 </c:pt>
                 <c:pt idx="4">
                   <c:v>82.5</c:v>
@@ -324,13 +324,13 @@
                   <c:v>1585</c:v>
                 </c:pt>
                 <c:pt idx="2">
-                  <c:v>1696</c:v>
+                  <c:v>1695</c:v>
                 </c:pt>
                 <c:pt idx="3">
-                  <c:v>1722</c:v>
+                  <c:v>1720</c:v>
                 </c:pt>
                 <c:pt idx="4">
-                  <c:v>1708</c:v>
+                  <c:v>1707</c:v>
                 </c:pt>
                 <c:pt idx="5">
                   <c:v>1705</c:v>
@@ -2773,7 +2773,7 @@
                           </a:solidFill>
                           <a:latin typeface="Arial"/>
                         </a:rPr>
-                        <a:t>≈ (1,696)</a:t>
+                        <a:t>≈ (1,695)</a:t>
                       </a:r>
                     </a:p>
                   </a:txBody>
@@ -3848,7 +3848,7 @@
                 </a:solidFill>
                 <a:latin typeface="Arial"/>
               </a:rPr>
-              <a:t>1,708</a:t>
+              <a:t>1,707</a:t>
             </a:r>
             <a:r>
               <a:rPr sz="1300" b="1" i="0">
@@ -3903,7 +3903,7 @@
                 </a:solidFill>
                 <a:latin typeface="Arial"/>
               </a:rPr>
-              <a:t>+292 gal (+21%) de autonomía entre recargas</a:t>
+              <a:t>+291 gal (+21%) de autonomía entre recargas</a:t>
             </a:r>
           </a:p>
           <a:p>
@@ -5272,7 +5272,7 @@
                           </a:solidFill>
                           <a:latin typeface="Arial"/>
                         </a:rPr>
-                        <a:t>1,696</a:t>
+                        <a:t>1,695</a:t>
                       </a:r>
                     </a:p>
                   </a:txBody>
@@ -5295,7 +5295,7 @@
                           </a:solidFill>
                           <a:latin typeface="Arial"/>
                         </a:rPr>
-                        <a:t>+19.8%</a:t>
+                        <a:t>+19.7%</a:t>
                       </a:r>
                     </a:p>
                   </a:txBody>
@@ -5412,7 +5412,7 @@
                           </a:solidFill>
                           <a:latin typeface="Arial"/>
                         </a:rPr>
-                        <a:t>1,722</a:t>
+                        <a:t>1,720</a:t>
                       </a:r>
                     </a:p>
                   </a:txBody>
@@ -5435,7 +5435,7 @@
                           </a:solidFill>
                           <a:latin typeface="Arial"/>
                         </a:rPr>
-                        <a:t>+21.6%</a:t>
+                        <a:t>+21.5%</a:t>
                       </a:r>
                     </a:p>
                   </a:txBody>
@@ -5552,7 +5552,7 @@
                           </a:solidFill>
                           <a:latin typeface="Arial"/>
                         </a:rPr>
-                        <a:t>1,708</a:t>
+                        <a:t>1,707</a:t>
                       </a:r>
                     </a:p>
                   </a:txBody>
@@ -5575,7 +5575,7 @@
                           </a:solidFill>
                           <a:latin typeface="Arial"/>
                         </a:rPr>
-                        <a:t>+20.6%</a:t>
+                        <a:t>+20.5%</a:t>
                       </a:r>
                     </a:p>
                   </a:txBody>
@@ -7750,7 +7750,7 @@
                 </a:solidFill>
                 <a:latin typeface="Arial"/>
               </a:rPr>
-              <a:t>Reduce la altura libre. La parte de la caja sobre el sensor de llenado no se usa: llega a 1,696 gal (4 gal bajo la meta).</a:t>
+              <a:t>Reduce la altura libre. La parte de la caja sobre el sensor de llenado no se usa: llega a 1,695 gal (5 gal bajo la meta).</a:t>
             </a:r>
           </a:p>
         </p:txBody>
@@ -7827,7 +7827,7 @@
                 </a:solidFill>
                 <a:latin typeface="Arial"/>
               </a:rPr>
-              <a:t>1,696</a:t>
+              <a:t>1,695</a:t>
             </a:r>
           </a:p>
         </p:txBody>
@@ -7872,7 +7872,7 @@
                 </a:solidFill>
                 <a:latin typeface="Arial"/>
               </a:rPr>
-              <a:t>+280 gal (+19.8%) vs actual</a:t>
+              <a:t>+279 gal (+19.7%) vs actual</a:t>
             </a:r>
           </a:p>
           <a:p>
@@ -7884,7 +7884,7 @@
                 </a:solidFill>
                 <a:latin typeface="Arial"/>
               </a:rPr>
-              <a:t>Bruto: 1,806 gal</a:t>
+              <a:t>Bruto: 1,805 gal</a:t>
             </a:r>
           </a:p>
         </p:txBody>
@@ -8139,7 +8139,7 @@
                           </a:solidFill>
                           <a:latin typeface="Arial"/>
                         </a:rPr>
-                        <a:t>+204</a:t>
+                        <a:t>+203</a:t>
                       </a:r>
                     </a:p>
                   </a:txBody>
@@ -8162,7 +8162,7 @@
                           </a:solidFill>
                           <a:latin typeface="Arial"/>
                         </a:rPr>
-                        <a:t>+204</a:t>
+                        <a:t>+203</a:t>
                       </a:r>
                     </a:p>
                   </a:txBody>
@@ -8185,7 +8185,7 @@
                           </a:solidFill>
                           <a:latin typeface="Arial"/>
                         </a:rPr>
-                        <a:t>68.0</a:t>
+                        <a:t>67.5</a:t>
                       </a:r>
                     </a:p>
                   </a:txBody>
@@ -8373,7 +8373,7 @@
                           </a:solidFill>
                           <a:latin typeface="Arial"/>
                         </a:rPr>
-                        <a:t>+293</a:t>
+                        <a:t>+292</a:t>
                       </a:r>
                     </a:p>
                   </a:txBody>
@@ -8396,7 +8396,7 @@
                           </a:solidFill>
                           <a:latin typeface="Arial"/>
                         </a:rPr>
-                        <a:t>+280</a:t>
+                        <a:t>+279</a:t>
                       </a:r>
                     </a:p>
                   </a:txBody>
@@ -9018,7 +9018,7 @@
                 </a:solidFill>
                 <a:latin typeface="Arial"/>
               </a:rPr>
-              <a:t>La mayor capacidad (1,722 gal) con bandas simples en todo el perímetro.</a:t>
+              <a:t>La mayor capacidad (1,720 gal) con bandas simples en todo el perímetro.</a:t>
             </a:r>
           </a:p>
           <a:p>
@@ -9120,7 +9120,7 @@
                 </a:solidFill>
                 <a:latin typeface="Arial"/>
               </a:rPr>
-              <a:t>1,722</a:t>
+              <a:t>1,720</a:t>
             </a:r>
           </a:p>
         </p:txBody>
@@ -9165,7 +9165,7 @@
                 </a:solidFill>
                 <a:latin typeface="Arial"/>
               </a:rPr>
-              <a:t>+306 gal (+21.6%) vs actual</a:t>
+              <a:t>+304 gal (+21.5%) vs actual</a:t>
             </a:r>
           </a:p>
           <a:p>
@@ -9177,7 +9177,7 @@
                 </a:solidFill>
                 <a:latin typeface="Arial"/>
               </a:rPr>
-              <a:t>Bruto: 1,819 gal</a:t>
+              <a:t>Bruto: 1,817 gal</a:t>
             </a:r>
           </a:p>
         </p:txBody>
@@ -9432,7 +9432,7 @@
                           </a:solidFill>
                           <a:latin typeface="Arial"/>
                         </a:rPr>
-                        <a:t>+204</a:t>
+                        <a:t>+203</a:t>
                       </a:r>
                     </a:p>
                   </a:txBody>
@@ -9455,7 +9455,7 @@
                           </a:solidFill>
                           <a:latin typeface="Arial"/>
                         </a:rPr>
-                        <a:t>+204</a:t>
+                        <a:t>+203</a:t>
                       </a:r>
                     </a:p>
                   </a:txBody>
@@ -9478,7 +9478,7 @@
                           </a:solidFill>
                           <a:latin typeface="Arial"/>
                         </a:rPr>
-                        <a:t>68.0</a:t>
+                        <a:t>67.5</a:t>
                       </a:r>
                     </a:p>
                   </a:txBody>
@@ -9561,7 +9561,7 @@
                           </a:solidFill>
                           <a:latin typeface="Arial"/>
                         </a:rPr>
-                        <a:t>+102</a:t>
+                        <a:t>+101</a:t>
                       </a:r>
                     </a:p>
                   </a:txBody>
@@ -9584,7 +9584,7 @@
                           </a:solidFill>
                           <a:latin typeface="Arial"/>
                         </a:rPr>
-                        <a:t>+102</a:t>
+                        <a:t>+101</a:t>
                       </a:r>
                     </a:p>
                   </a:txBody>
@@ -9607,7 +9607,7 @@
                           </a:solidFill>
                           <a:latin typeface="Arial"/>
                         </a:rPr>
-                        <a:t>68.0</a:t>
+                        <a:t>67.5</a:t>
                       </a:r>
                     </a:p>
                   </a:txBody>
@@ -9678,7 +9678,7 @@
                           </a:solidFill>
                           <a:latin typeface="Arial"/>
                         </a:rPr>
-                        <a:t>+306</a:t>
+                        <a:t>+304</a:t>
                       </a:r>
                     </a:p>
                   </a:txBody>
@@ -9701,7 +9701,7 @@
                           </a:solidFill>
                           <a:latin typeface="Arial"/>
                         </a:rPr>
-                        <a:t>+306</a:t>
+                        <a:t>+304</a:t>
                       </a:r>
                     </a:p>
                   </a:txBody>
@@ -10425,7 +10425,7 @@
                 </a:solidFill>
                 <a:latin typeface="Arial"/>
               </a:rPr>
-              <a:t>1,708</a:t>
+              <a:t>1,707</a:t>
             </a:r>
           </a:p>
         </p:txBody>
@@ -10470,7 +10470,7 @@
                 </a:solidFill>
                 <a:latin typeface="Arial"/>
               </a:rPr>
-              <a:t>+292 gal (+20.6%) vs actual</a:t>
+              <a:t>+291 gal (+20.5%) vs actual</a:t>
             </a:r>
           </a:p>
           <a:p>
@@ -10482,7 +10482,7 @@
                 </a:solidFill>
                 <a:latin typeface="Arial"/>
               </a:rPr>
-              <a:t>Bruto: 1,817 gal</a:t>
+              <a:t>Bruto: 1,816 gal</a:t>
             </a:r>
           </a:p>
         </p:txBody>
@@ -10866,7 +10866,7 @@
                           </a:solidFill>
                           <a:latin typeface="Arial"/>
                         </a:rPr>
-                        <a:t>+122</a:t>
+                        <a:t>+121</a:t>
                       </a:r>
                     </a:p>
                   </a:txBody>
@@ -10889,7 +10889,7 @@
                           </a:solidFill>
                           <a:latin typeface="Arial"/>
                         </a:rPr>
-                        <a:t>+122</a:t>
+                        <a:t>+121</a:t>
                       </a:r>
                     </a:p>
                   </a:txBody>
@@ -10912,7 +10912,7 @@
                           </a:solidFill>
                           <a:latin typeface="Arial"/>
                         </a:rPr>
-                        <a:t>76.1</a:t>
+                        <a:t>75.7</a:t>
                       </a:r>
                     </a:p>
                   </a:txBody>
@@ -11006,7 +11006,7 @@
                           </a:solidFill>
                           <a:latin typeface="Arial"/>
                         </a:rPr>
-                        <a:t>+292</a:t>
+                        <a:t>+291</a:t>
                       </a:r>
                     </a:p>
                   </a:txBody>

</xml_diff>